<commit_message>
docs: sync latest presentation pitch deck in dokumentasi folder
</commit_message>
<xml_diff>
--- a/dokumentasi/GluPulse_AI_Pitch_Deck.pptx
+++ b/dokumentasi/GluPulse_AI_Pitch_Deck.pptx
@@ -114,24 +114,24 @@
   <p:extLst>
     <p:ext uri="{521415D9-36F7-43E2-AB2F-B90AF26B5E84}">
       <p14:sectionLst xmlns:p14="http://schemas.microsoft.com/office/powerpoint/2010/main">
-        <p14:section name="Pembuka" id="{0122e0ec-77ad-eaa5-01c0-b8adbc9d4063}">
+        <p14:section name="Pembuka" id="{b9d94574-2c5f-4281-a138-b265007f4534}">
           <p14:sldIdLst>
             <p14:sldId id="256"/>
           </p14:sldIdLst>
         </p14:section>
-        <p14:section name="Masalah &amp; Solusi" id="{db438fe0-68ae-1658-5e6c-dc56c191508a}">
+        <p14:section name="Masalah &amp; Solusi" id="{d4abad8b-df6a-ad1e-8007-ceaf566c2532}">
           <p14:sldIdLst>
             <p14:sldId id="257"/>
             <p14:sldId id="258"/>
             <p14:sldId id="259"/>
           </p14:sldIdLst>
         </p14:section>
-        <p14:section name="Arsitektur" id="{a5ffaedf-13ab-e653-9864-b4135be8aacc}">
+        <p14:section name="Arsitektur" id="{32336d74-e818-8746-737e-4cd33780491a}">
           <p14:sldIdLst>
             <p14:sldId id="260"/>
           </p14:sldIdLst>
         </p14:section>
-        <p14:section name="Demo &amp; Dampak" id="{2e68d121-0e19-d804-049b-d7c23fabc8b8}">
+        <p14:section name="Demo &amp; Dampak" id="{9f907bc8-c2a1-df0d-0fea-add8d713bcfb}">
           <p14:sldIdLst>
             <p14:sldId id="261"/>
             <p14:sldId id="262"/>
@@ -1996,7 +1996,7 @@
         <p:spPr>
           <a:xfrm>
             <a:off x="3337560" y="731520"/>
-            <a:ext cx="2743200" cy="384048"/>
+            <a:ext cx="2697480" cy="384048"/>
           </a:xfrm>
           <a:prstGeom prst="roundRect">
             <a:avLst>
@@ -2021,7 +2021,7 @@
                   <a:schemeClr val="bg1"/>
                 </a:solidFill>
               </a:rPr>
-              <a:t>Tim: [Nama Tim / Inisiator]</a:t>
+              <a:t>Farhan Triputra Ramadhan</a:t>
             </a:r>
             <a:endParaRPr lang="en-US" sz="1200" dirty="0"/>
           </a:p>
@@ -7807,7 +7807,7 @@
                   <a:schemeClr val="tx2"/>
                 </a:solidFill>
               </a:rPr>
-              <a:t>Kontak: [nama tim · email]</a:t>
+              <a:t>Farhan Triputra Ramadhan</a:t>
             </a:r>
             <a:endParaRPr lang="en-US" sz="1400" dirty="0"/>
           </a:p>

</xml_diff>